<commit_message>
Fix paths and add requirements
</commit_message>
<xml_diff>
--- a/EduLens_AI_Pitch_Deck.pptx
+++ b/EduLens_AI_Pitch_Deck.pptx
@@ -5,18 +5,18 @@
     <p:sldMasterId id="2147483648" r:id="rId1"/>
   </p:sldMasterIdLst>
   <p:sldIdLst>
-    <p:sldId id="256" r:id="rId7"/>
-    <p:sldId id="257" r:id="rId8"/>
-    <p:sldId id="258" r:id="rId9"/>
-    <p:sldId id="259" r:id="rId10"/>
-    <p:sldId id="260" r:id="rId11"/>
-    <p:sldId id="261" r:id="rId12"/>
-    <p:sldId id="262" r:id="rId13"/>
-    <p:sldId id="263" r:id="rId14"/>
-    <p:sldId id="264" r:id="rId15"/>
-    <p:sldId id="265" r:id="rId16"/>
+    <p:sldId id="256" r:id="rId2"/>
+    <p:sldId id="257" r:id="rId3"/>
+    <p:sldId id="258" r:id="rId4"/>
+    <p:sldId id="259" r:id="rId5"/>
+    <p:sldId id="260" r:id="rId6"/>
+    <p:sldId id="261" r:id="rId7"/>
+    <p:sldId id="262" r:id="rId8"/>
+    <p:sldId id="263" r:id="rId9"/>
+    <p:sldId id="264" r:id="rId10"/>
+    <p:sldId id="265" r:id="rId11"/>
   </p:sldIdLst>
-  <p:sldSz cx="12188952" cy="6858000" type="screen4x3"/>
+  <p:sldSz cx="12188825" cy="6858000"/>
   <p:notesSz cx="6858000" cy="9144000"/>
   <p:defaultTextStyle>
     <a:defPPr>
@@ -113,7 +113,60 @@
       </a:defRPr>
     </a:lvl9pPr>
   </p:defaultTextStyle>
+  <p:extLst>
+    <p:ext uri="{EFAFB233-063F-42B5-8137-9DF3F51BA10A}">
+      <p15:sldGuideLst xmlns:p15="http://schemas.microsoft.com/office/powerpoint/2012/main">
+        <p15:guide id="1" orient="horz" pos="2160">
+          <p15:clr>
+            <a:srgbClr val="A4A3A4"/>
+          </p15:clr>
+        </p15:guide>
+        <p15:guide id="2" pos="2880">
+          <p15:clr>
+            <a:srgbClr val="A4A3A4"/>
+          </p15:clr>
+        </p15:guide>
+      </p15:sldGuideLst>
+    </p:ext>
+  </p:extLst>
 </p:presentation>
+</file>
+
+<file path=ppt/changesInfos/changesInfo1.xml><?xml version="1.0" encoding="utf-8"?>
+<pc:chgInfo xmlns:a="http://schemas.openxmlformats.org/drawingml/2006/main" xmlns:r="http://schemas.openxmlformats.org/officeDocument/2006/relationships" xmlns:ac="http://schemas.microsoft.com/office/drawing/2013/main/command" xmlns:pc="http://schemas.microsoft.com/office/powerpoint/2013/main/command">
+  <pc:docChgLst>
+    <pc:chgData name="Vaishnavi Singasani" userId="71bafadd02fe83d1" providerId="LiveId" clId="{1710BE2F-9429-4125-9A33-040E7F906FBD}"/>
+    <pc:docChg chg="modSld">
+      <pc:chgData name="Vaishnavi Singasani" userId="71bafadd02fe83d1" providerId="LiveId" clId="{1710BE2F-9429-4125-9A33-040E7F906FBD}" dt="2026-04-07T11:53:03.298" v="12" actId="14100"/>
+      <pc:docMkLst>
+        <pc:docMk/>
+      </pc:docMkLst>
+      <pc:sldChg chg="addSp modSp mod">
+        <pc:chgData name="Vaishnavi Singasani" userId="71bafadd02fe83d1" providerId="LiveId" clId="{1710BE2F-9429-4125-9A33-040E7F906FBD}" dt="2026-04-07T11:53:03.298" v="12" actId="14100"/>
+        <pc:sldMkLst>
+          <pc:docMk/>
+          <pc:sldMk cId="0" sldId="259"/>
+        </pc:sldMkLst>
+        <pc:picChg chg="add mod">
+          <ac:chgData name="Vaishnavi Singasani" userId="71bafadd02fe83d1" providerId="LiveId" clId="{1710BE2F-9429-4125-9A33-040E7F906FBD}" dt="2026-04-07T11:51:32.165" v="6" actId="14100"/>
+          <ac:picMkLst>
+            <pc:docMk/>
+            <pc:sldMk cId="0" sldId="259"/>
+            <ac:picMk id="10" creationId="{D624933B-CFA8-B84D-6796-22BFC81624A2}"/>
+          </ac:picMkLst>
+        </pc:picChg>
+        <pc:picChg chg="add mod">
+          <ac:chgData name="Vaishnavi Singasani" userId="71bafadd02fe83d1" providerId="LiveId" clId="{1710BE2F-9429-4125-9A33-040E7F906FBD}" dt="2026-04-07T11:53:03.298" v="12" actId="14100"/>
+          <ac:picMkLst>
+            <pc:docMk/>
+            <pc:sldMk cId="0" sldId="259"/>
+            <ac:picMk id="12" creationId="{901E060D-D31E-58C2-8AA3-515983F80EBA}"/>
+          </ac:picMkLst>
+        </pc:picChg>
+      </pc:sldChg>
+    </pc:docChg>
+  </pc:docChgLst>
+</pc:chgInfo>
 </file>
 
 <file path=ppt/slideLayouts/slideLayout1.xml><?xml version="1.0" encoding="utf-8"?>
@@ -154,10 +207,9 @@
           <a:lstStyle/>
           <a:p>
             <a:r>
-              <a:rPr lang="en-US" smtClean="0"/>
+              <a:rPr lang="en-US"/>
               <a:t>Click to edit Master title style</a:t>
             </a:r>
-            <a:endParaRPr lang="en-US"/>
           </a:p>
         </p:txBody>
       </p:sp>
@@ -273,10 +325,9 @@
           </a:lstStyle>
           <a:p>
             <a:r>
-              <a:rPr lang="en-US" smtClean="0"/>
+              <a:rPr lang="en-US"/>
               <a:t>Click to edit Master subtitle style</a:t>
             </a:r>
-            <a:endParaRPr lang="en-US"/>
           </a:p>
         </p:txBody>
       </p:sp>
@@ -297,7 +348,7 @@
           <a:p>
             <a:fld id="{5BCAD085-E8A6-8845-BD4E-CB4CCA059FC4}" type="datetimeFigureOut">
               <a:rPr lang="en-US" smtClean="0"/>
-              <a:t>1/27/13</a:t>
+              <a:t>4/7/2026</a:t>
             </a:fld>
             <a:endParaRPr lang="en-US"/>
           </a:p>
@@ -391,10 +442,9 @@
           <a:lstStyle/>
           <a:p>
             <a:r>
-              <a:rPr lang="en-US" smtClean="0"/>
+              <a:rPr lang="en-US"/>
               <a:t>Click to edit Master title style</a:t>
             </a:r>
-            <a:endParaRPr lang="en-US"/>
           </a:p>
         </p:txBody>
       </p:sp>
@@ -415,38 +465,37 @@
           <a:p>
             <a:pPr lvl="0"/>
             <a:r>
-              <a:rPr lang="en-US" smtClean="0"/>
+              <a:rPr lang="en-US"/>
               <a:t>Click to edit Master text styles</a:t>
             </a:r>
           </a:p>
           <a:p>
             <a:pPr lvl="1"/>
             <a:r>
-              <a:rPr lang="en-US" smtClean="0"/>
+              <a:rPr lang="en-US"/>
               <a:t>Second level</a:t>
             </a:r>
           </a:p>
           <a:p>
             <a:pPr lvl="2"/>
             <a:r>
-              <a:rPr lang="en-US" smtClean="0"/>
+              <a:rPr lang="en-US"/>
               <a:t>Third level</a:t>
             </a:r>
           </a:p>
           <a:p>
             <a:pPr lvl="3"/>
             <a:r>
-              <a:rPr lang="en-US" smtClean="0"/>
+              <a:rPr lang="en-US"/>
               <a:t>Fourth level</a:t>
             </a:r>
           </a:p>
           <a:p>
             <a:pPr lvl="4"/>
             <a:r>
-              <a:rPr lang="en-US" smtClean="0"/>
+              <a:rPr lang="en-US"/>
               <a:t>Fifth level</a:t>
             </a:r>
-            <a:endParaRPr lang="en-US"/>
           </a:p>
         </p:txBody>
       </p:sp>
@@ -467,7 +516,7 @@
           <a:p>
             <a:fld id="{5BCAD085-E8A6-8845-BD4E-CB4CCA059FC4}" type="datetimeFigureOut">
               <a:rPr lang="en-US" smtClean="0"/>
-              <a:t>1/27/13</a:t>
+              <a:t>4/7/2026</a:t>
             </a:fld>
             <a:endParaRPr lang="en-US"/>
           </a:p>
@@ -566,10 +615,9 @@
           <a:lstStyle/>
           <a:p>
             <a:r>
-              <a:rPr lang="en-US" smtClean="0"/>
+              <a:rPr lang="en-US"/>
               <a:t>Click to edit Master title style</a:t>
             </a:r>
-            <a:endParaRPr lang="en-US"/>
           </a:p>
         </p:txBody>
       </p:sp>
@@ -595,38 +643,37 @@
           <a:p>
             <a:pPr lvl="0"/>
             <a:r>
-              <a:rPr lang="en-US" smtClean="0"/>
+              <a:rPr lang="en-US"/>
               <a:t>Click to edit Master text styles</a:t>
             </a:r>
           </a:p>
           <a:p>
             <a:pPr lvl="1"/>
             <a:r>
-              <a:rPr lang="en-US" smtClean="0"/>
+              <a:rPr lang="en-US"/>
               <a:t>Second level</a:t>
             </a:r>
           </a:p>
           <a:p>
             <a:pPr lvl="2"/>
             <a:r>
-              <a:rPr lang="en-US" smtClean="0"/>
+              <a:rPr lang="en-US"/>
               <a:t>Third level</a:t>
             </a:r>
           </a:p>
           <a:p>
             <a:pPr lvl="3"/>
             <a:r>
-              <a:rPr lang="en-US" smtClean="0"/>
+              <a:rPr lang="en-US"/>
               <a:t>Fourth level</a:t>
             </a:r>
           </a:p>
           <a:p>
             <a:pPr lvl="4"/>
             <a:r>
-              <a:rPr lang="en-US" smtClean="0"/>
+              <a:rPr lang="en-US"/>
               <a:t>Fifth level</a:t>
             </a:r>
-            <a:endParaRPr lang="en-US"/>
           </a:p>
         </p:txBody>
       </p:sp>
@@ -647,7 +694,7 @@
           <a:p>
             <a:fld id="{5BCAD085-E8A6-8845-BD4E-CB4CCA059FC4}" type="datetimeFigureOut">
               <a:rPr lang="en-US" smtClean="0"/>
-              <a:t>1/27/13</a:t>
+              <a:t>4/7/2026</a:t>
             </a:fld>
             <a:endParaRPr lang="en-US"/>
           </a:p>
@@ -741,10 +788,9 @@
           <a:lstStyle/>
           <a:p>
             <a:r>
-              <a:rPr lang="en-US" smtClean="0"/>
+              <a:rPr lang="en-US"/>
               <a:t>Click to edit Master title style</a:t>
             </a:r>
-            <a:endParaRPr lang="en-US"/>
           </a:p>
         </p:txBody>
       </p:sp>
@@ -765,38 +811,37 @@
           <a:p>
             <a:pPr lvl="0"/>
             <a:r>
-              <a:rPr lang="en-US" smtClean="0"/>
+              <a:rPr lang="en-US"/>
               <a:t>Click to edit Master text styles</a:t>
             </a:r>
           </a:p>
           <a:p>
             <a:pPr lvl="1"/>
             <a:r>
-              <a:rPr lang="en-US" smtClean="0"/>
+              <a:rPr lang="en-US"/>
               <a:t>Second level</a:t>
             </a:r>
           </a:p>
           <a:p>
             <a:pPr lvl="2"/>
             <a:r>
-              <a:rPr lang="en-US" smtClean="0"/>
+              <a:rPr lang="en-US"/>
               <a:t>Third level</a:t>
             </a:r>
           </a:p>
           <a:p>
             <a:pPr lvl="3"/>
             <a:r>
-              <a:rPr lang="en-US" smtClean="0"/>
+              <a:rPr lang="en-US"/>
               <a:t>Fourth level</a:t>
             </a:r>
           </a:p>
           <a:p>
             <a:pPr lvl="4"/>
             <a:r>
-              <a:rPr lang="en-US" smtClean="0"/>
+              <a:rPr lang="en-US"/>
               <a:t>Fifth level</a:t>
             </a:r>
-            <a:endParaRPr lang="en-US"/>
           </a:p>
         </p:txBody>
       </p:sp>
@@ -817,7 +862,7 @@
           <a:p>
             <a:fld id="{5BCAD085-E8A6-8845-BD4E-CB4CCA059FC4}" type="datetimeFigureOut">
               <a:rPr lang="en-US" smtClean="0"/>
-              <a:t>1/27/13</a:t>
+              <a:t>4/7/2026</a:t>
             </a:fld>
             <a:endParaRPr lang="en-US"/>
           </a:p>
@@ -920,10 +965,9 @@
           </a:lstStyle>
           <a:p>
             <a:r>
-              <a:rPr lang="en-US" smtClean="0"/>
+              <a:rPr lang="en-US"/>
               <a:t>Click to edit Master title style</a:t>
             </a:r>
-            <a:endParaRPr lang="en-US"/>
           </a:p>
         </p:txBody>
       </p:sp>
@@ -1040,7 +1084,7 @@
           <a:p>
             <a:pPr lvl="0"/>
             <a:r>
-              <a:rPr lang="en-US" smtClean="0"/>
+              <a:rPr lang="en-US"/>
               <a:t>Click to edit Master text styles</a:t>
             </a:r>
           </a:p>
@@ -1063,7 +1107,7 @@
           <a:p>
             <a:fld id="{5BCAD085-E8A6-8845-BD4E-CB4CCA059FC4}" type="datetimeFigureOut">
               <a:rPr lang="en-US" smtClean="0"/>
-              <a:t>1/27/13</a:t>
+              <a:t>4/7/2026</a:t>
             </a:fld>
             <a:endParaRPr lang="en-US"/>
           </a:p>
@@ -1157,10 +1201,9 @@
           <a:lstStyle/>
           <a:p>
             <a:r>
-              <a:rPr lang="en-US" smtClean="0"/>
+              <a:rPr lang="en-US"/>
               <a:t>Click to edit Master title style</a:t>
             </a:r>
-            <a:endParaRPr lang="en-US"/>
           </a:p>
         </p:txBody>
       </p:sp>
@@ -1214,38 +1257,37 @@
           <a:p>
             <a:pPr lvl="0"/>
             <a:r>
-              <a:rPr lang="en-US" smtClean="0"/>
+              <a:rPr lang="en-US"/>
               <a:t>Click to edit Master text styles</a:t>
             </a:r>
           </a:p>
           <a:p>
             <a:pPr lvl="1"/>
             <a:r>
-              <a:rPr lang="en-US" smtClean="0"/>
+              <a:rPr lang="en-US"/>
               <a:t>Second level</a:t>
             </a:r>
           </a:p>
           <a:p>
             <a:pPr lvl="2"/>
             <a:r>
-              <a:rPr lang="en-US" smtClean="0"/>
+              <a:rPr lang="en-US"/>
               <a:t>Third level</a:t>
             </a:r>
           </a:p>
           <a:p>
             <a:pPr lvl="3"/>
             <a:r>
-              <a:rPr lang="en-US" smtClean="0"/>
+              <a:rPr lang="en-US"/>
               <a:t>Fourth level</a:t>
             </a:r>
           </a:p>
           <a:p>
             <a:pPr lvl="4"/>
             <a:r>
-              <a:rPr lang="en-US" smtClean="0"/>
+              <a:rPr lang="en-US"/>
               <a:t>Fifth level</a:t>
             </a:r>
-            <a:endParaRPr lang="en-US"/>
           </a:p>
         </p:txBody>
       </p:sp>
@@ -1299,38 +1341,37 @@
           <a:p>
             <a:pPr lvl="0"/>
             <a:r>
-              <a:rPr lang="en-US" smtClean="0"/>
+              <a:rPr lang="en-US"/>
               <a:t>Click to edit Master text styles</a:t>
             </a:r>
           </a:p>
           <a:p>
             <a:pPr lvl="1"/>
             <a:r>
-              <a:rPr lang="en-US" smtClean="0"/>
+              <a:rPr lang="en-US"/>
               <a:t>Second level</a:t>
             </a:r>
           </a:p>
           <a:p>
             <a:pPr lvl="2"/>
             <a:r>
-              <a:rPr lang="en-US" smtClean="0"/>
+              <a:rPr lang="en-US"/>
               <a:t>Third level</a:t>
             </a:r>
           </a:p>
           <a:p>
             <a:pPr lvl="3"/>
             <a:r>
-              <a:rPr lang="en-US" smtClean="0"/>
+              <a:rPr lang="en-US"/>
               <a:t>Fourth level</a:t>
             </a:r>
           </a:p>
           <a:p>
             <a:pPr lvl="4"/>
             <a:r>
-              <a:rPr lang="en-US" smtClean="0"/>
+              <a:rPr lang="en-US"/>
               <a:t>Fifth level</a:t>
             </a:r>
-            <a:endParaRPr lang="en-US"/>
           </a:p>
         </p:txBody>
       </p:sp>
@@ -1351,7 +1392,7 @@
           <a:p>
             <a:fld id="{5BCAD085-E8A6-8845-BD4E-CB4CCA059FC4}" type="datetimeFigureOut">
               <a:rPr lang="en-US" smtClean="0"/>
-              <a:t>1/27/13</a:t>
+              <a:t>4/7/2026</a:t>
             </a:fld>
             <a:endParaRPr lang="en-US"/>
           </a:p>
@@ -1449,10 +1490,9 @@
           </a:lstStyle>
           <a:p>
             <a:r>
-              <a:rPr lang="en-US" smtClean="0"/>
+              <a:rPr lang="en-US"/>
               <a:t>Click to edit Master title style</a:t>
             </a:r>
-            <a:endParaRPr lang="en-US"/>
           </a:p>
         </p:txBody>
       </p:sp>
@@ -1515,7 +1555,7 @@
           <a:p>
             <a:pPr lvl="0"/>
             <a:r>
-              <a:rPr lang="en-US" smtClean="0"/>
+              <a:rPr lang="en-US"/>
               <a:t>Click to edit Master text styles</a:t>
             </a:r>
           </a:p>
@@ -1571,38 +1611,37 @@
           <a:p>
             <a:pPr lvl="0"/>
             <a:r>
-              <a:rPr lang="en-US" smtClean="0"/>
+              <a:rPr lang="en-US"/>
               <a:t>Click to edit Master text styles</a:t>
             </a:r>
           </a:p>
           <a:p>
             <a:pPr lvl="1"/>
             <a:r>
-              <a:rPr lang="en-US" smtClean="0"/>
+              <a:rPr lang="en-US"/>
               <a:t>Second level</a:t>
             </a:r>
           </a:p>
           <a:p>
             <a:pPr lvl="2"/>
             <a:r>
-              <a:rPr lang="en-US" smtClean="0"/>
+              <a:rPr lang="en-US"/>
               <a:t>Third level</a:t>
             </a:r>
           </a:p>
           <a:p>
             <a:pPr lvl="3"/>
             <a:r>
-              <a:rPr lang="en-US" smtClean="0"/>
+              <a:rPr lang="en-US"/>
               <a:t>Fourth level</a:t>
             </a:r>
           </a:p>
           <a:p>
             <a:pPr lvl="4"/>
             <a:r>
-              <a:rPr lang="en-US" smtClean="0"/>
+              <a:rPr lang="en-US"/>
               <a:t>Fifth level</a:t>
             </a:r>
-            <a:endParaRPr lang="en-US"/>
           </a:p>
         </p:txBody>
       </p:sp>
@@ -1665,7 +1704,7 @@
           <a:p>
             <a:pPr lvl="0"/>
             <a:r>
-              <a:rPr lang="en-US" smtClean="0"/>
+              <a:rPr lang="en-US"/>
               <a:t>Click to edit Master text styles</a:t>
             </a:r>
           </a:p>
@@ -1721,38 +1760,37 @@
           <a:p>
             <a:pPr lvl="0"/>
             <a:r>
-              <a:rPr lang="en-US" smtClean="0"/>
+              <a:rPr lang="en-US"/>
               <a:t>Click to edit Master text styles</a:t>
             </a:r>
           </a:p>
           <a:p>
             <a:pPr lvl="1"/>
             <a:r>
-              <a:rPr lang="en-US" smtClean="0"/>
+              <a:rPr lang="en-US"/>
               <a:t>Second level</a:t>
             </a:r>
           </a:p>
           <a:p>
             <a:pPr lvl="2"/>
             <a:r>
-              <a:rPr lang="en-US" smtClean="0"/>
+              <a:rPr lang="en-US"/>
               <a:t>Third level</a:t>
             </a:r>
           </a:p>
           <a:p>
             <a:pPr lvl="3"/>
             <a:r>
-              <a:rPr lang="en-US" smtClean="0"/>
+              <a:rPr lang="en-US"/>
               <a:t>Fourth level</a:t>
             </a:r>
           </a:p>
           <a:p>
             <a:pPr lvl="4"/>
             <a:r>
-              <a:rPr lang="en-US" smtClean="0"/>
+              <a:rPr lang="en-US"/>
               <a:t>Fifth level</a:t>
             </a:r>
-            <a:endParaRPr lang="en-US"/>
           </a:p>
         </p:txBody>
       </p:sp>
@@ -1773,7 +1811,7 @@
           <a:p>
             <a:fld id="{5BCAD085-E8A6-8845-BD4E-CB4CCA059FC4}" type="datetimeFigureOut">
               <a:rPr lang="en-US" smtClean="0"/>
-              <a:t>1/27/13</a:t>
+              <a:t>4/7/2026</a:t>
             </a:fld>
             <a:endParaRPr lang="en-US"/>
           </a:p>
@@ -1867,10 +1905,9 @@
           <a:lstStyle/>
           <a:p>
             <a:r>
-              <a:rPr lang="en-US" smtClean="0"/>
+              <a:rPr lang="en-US"/>
               <a:t>Click to edit Master title style</a:t>
             </a:r>
-            <a:endParaRPr lang="en-US"/>
           </a:p>
         </p:txBody>
       </p:sp>
@@ -1891,7 +1928,7 @@
           <a:p>
             <a:fld id="{5BCAD085-E8A6-8845-BD4E-CB4CCA059FC4}" type="datetimeFigureOut">
               <a:rPr lang="en-US" smtClean="0"/>
-              <a:t>1/27/13</a:t>
+              <a:t>4/7/2026</a:t>
             </a:fld>
             <a:endParaRPr lang="en-US"/>
           </a:p>
@@ -1986,7 +2023,7 @@
           <a:p>
             <a:fld id="{5BCAD085-E8A6-8845-BD4E-CB4CCA059FC4}" type="datetimeFigureOut">
               <a:rPr lang="en-US" smtClean="0"/>
-              <a:t>1/27/13</a:t>
+              <a:t>4/7/2026</a:t>
             </a:fld>
             <a:endParaRPr lang="en-US"/>
           </a:p>
@@ -2089,10 +2126,9 @@
           </a:lstStyle>
           <a:p>
             <a:r>
-              <a:rPr lang="en-US" smtClean="0"/>
+              <a:rPr lang="en-US"/>
               <a:t>Click to edit Master title style</a:t>
             </a:r>
-            <a:endParaRPr lang="en-US"/>
           </a:p>
         </p:txBody>
       </p:sp>
@@ -2146,38 +2182,37 @@
           <a:p>
             <a:pPr lvl="0"/>
             <a:r>
-              <a:rPr lang="en-US" smtClean="0"/>
+              <a:rPr lang="en-US"/>
               <a:t>Click to edit Master text styles</a:t>
             </a:r>
           </a:p>
           <a:p>
             <a:pPr lvl="1"/>
             <a:r>
-              <a:rPr lang="en-US" smtClean="0"/>
+              <a:rPr lang="en-US"/>
               <a:t>Second level</a:t>
             </a:r>
           </a:p>
           <a:p>
             <a:pPr lvl="2"/>
             <a:r>
-              <a:rPr lang="en-US" smtClean="0"/>
+              <a:rPr lang="en-US"/>
               <a:t>Third level</a:t>
             </a:r>
           </a:p>
           <a:p>
             <a:pPr lvl="3"/>
             <a:r>
-              <a:rPr lang="en-US" smtClean="0"/>
+              <a:rPr lang="en-US"/>
               <a:t>Fourth level</a:t>
             </a:r>
           </a:p>
           <a:p>
             <a:pPr lvl="4"/>
             <a:r>
-              <a:rPr lang="en-US" smtClean="0"/>
+              <a:rPr lang="en-US"/>
               <a:t>Fifth level</a:t>
             </a:r>
-            <a:endParaRPr lang="en-US"/>
           </a:p>
         </p:txBody>
       </p:sp>
@@ -2240,7 +2275,7 @@
           <a:p>
             <a:pPr lvl="0"/>
             <a:r>
-              <a:rPr lang="en-US" smtClean="0"/>
+              <a:rPr lang="en-US"/>
               <a:t>Click to edit Master text styles</a:t>
             </a:r>
           </a:p>
@@ -2263,7 +2298,7 @@
           <a:p>
             <a:fld id="{5BCAD085-E8A6-8845-BD4E-CB4CCA059FC4}" type="datetimeFigureOut">
               <a:rPr lang="en-US" smtClean="0"/>
-              <a:t>1/27/13</a:t>
+              <a:t>4/7/2026</a:t>
             </a:fld>
             <a:endParaRPr lang="en-US"/>
           </a:p>
@@ -2366,10 +2401,9 @@
           </a:lstStyle>
           <a:p>
             <a:r>
-              <a:rPr lang="en-US" smtClean="0"/>
+              <a:rPr lang="en-US"/>
               <a:t>Click to edit Master title style</a:t>
             </a:r>
-            <a:endParaRPr lang="en-US"/>
           </a:p>
         </p:txBody>
       </p:sp>
@@ -2493,7 +2527,7 @@
           <a:p>
             <a:pPr lvl="0"/>
             <a:r>
-              <a:rPr lang="en-US" smtClean="0"/>
+              <a:rPr lang="en-US"/>
               <a:t>Click to edit Master text styles</a:t>
             </a:r>
           </a:p>
@@ -2516,7 +2550,7 @@
           <a:p>
             <a:fld id="{5BCAD085-E8A6-8845-BD4E-CB4CCA059FC4}" type="datetimeFigureOut">
               <a:rPr lang="en-US" smtClean="0"/>
-              <a:t>1/27/13</a:t>
+              <a:t>4/7/2026</a:t>
             </a:fld>
             <a:endParaRPr lang="en-US"/>
           </a:p>
@@ -2625,10 +2659,9 @@
           <a:lstStyle/>
           <a:p>
             <a:r>
-              <a:rPr lang="en-US" smtClean="0"/>
+              <a:rPr lang="en-US"/>
               <a:t>Click to edit Master title style</a:t>
             </a:r>
-            <a:endParaRPr lang="en-US"/>
           </a:p>
         </p:txBody>
       </p:sp>
@@ -2659,38 +2692,37 @@
           <a:p>
             <a:pPr lvl="0"/>
             <a:r>
-              <a:rPr lang="en-US" smtClean="0"/>
+              <a:rPr lang="en-US"/>
               <a:t>Click to edit Master text styles</a:t>
             </a:r>
           </a:p>
           <a:p>
             <a:pPr lvl="1"/>
             <a:r>
-              <a:rPr lang="en-US" smtClean="0"/>
+              <a:rPr lang="en-US"/>
               <a:t>Second level</a:t>
             </a:r>
           </a:p>
           <a:p>
             <a:pPr lvl="2"/>
             <a:r>
-              <a:rPr lang="en-US" smtClean="0"/>
+              <a:rPr lang="en-US"/>
               <a:t>Third level</a:t>
             </a:r>
           </a:p>
           <a:p>
             <a:pPr lvl="3"/>
             <a:r>
-              <a:rPr lang="en-US" smtClean="0"/>
+              <a:rPr lang="en-US"/>
               <a:t>Fourth level</a:t>
             </a:r>
           </a:p>
           <a:p>
             <a:pPr lvl="4"/>
             <a:r>
-              <a:rPr lang="en-US" smtClean="0"/>
+              <a:rPr lang="en-US"/>
               <a:t>Fifth level</a:t>
             </a:r>
-            <a:endParaRPr lang="en-US"/>
           </a:p>
         </p:txBody>
       </p:sp>
@@ -2729,7 +2761,7 @@
           <a:p>
             <a:fld id="{5BCAD085-E8A6-8845-BD4E-CB4CCA059FC4}" type="datetimeFigureOut">
               <a:rPr lang="en-US" smtClean="0"/>
-              <a:t>1/27/13</a:t>
+              <a:t>4/7/2026</a:t>
             </a:fld>
             <a:endParaRPr lang="en-US"/>
           </a:p>
@@ -3088,7 +3120,7 @@
 </file>
 
 <file path=ppt/slides/slide1.xml><?xml version="1.0" encoding="utf-8"?>
-<p:sld xmlns:a="http://schemas.openxmlformats.org/drawingml/2006/main" xmlns:p="http://schemas.openxmlformats.org/presentationml/2006/main" xmlns:r="http://schemas.openxmlformats.org/officeDocument/2006/relationships">
+<p:sld xmlns:a="http://schemas.openxmlformats.org/drawingml/2006/main" xmlns:r="http://schemas.openxmlformats.org/officeDocument/2006/relationships" xmlns:p="http://schemas.openxmlformats.org/presentationml/2006/main">
   <p:cSld>
     <p:bg>
       <p:bgPr>
@@ -3104,7 +3136,14 @@
         <p:cNvGrpSpPr/>
         <p:nvPr/>
       </p:nvGrpSpPr>
-      <p:grpSpPr/>
+      <p:grpSpPr>
+        <a:xfrm>
+          <a:off x="0" y="0"/>
+          <a:ext cx="0" cy="0"/>
+          <a:chOff x="0" y="0"/>
+          <a:chExt cx="0" cy="0"/>
+        </a:xfrm>
+      </p:grpSpPr>
       <p:sp>
         <p:nvSpPr>
           <p:cNvPr id="2" name="Rectangle 1"/>
@@ -3145,6 +3184,7 @@
           <a:lstStyle/>
           <a:p>
             <a:pPr algn="ctr"/>
+            <a:endParaRPr/>
           </a:p>
         </p:txBody>
       </p:sp>
@@ -3188,6 +3228,7 @@
           <a:lstStyle/>
           <a:p>
             <a:pPr algn="ctr"/>
+            <a:endParaRPr/>
           </a:p>
         </p:txBody>
       </p:sp>
@@ -3370,7 +3411,7 @@
 </file>
 
 <file path=ppt/slides/slide10.xml><?xml version="1.0" encoding="utf-8"?>
-<p:sld xmlns:a="http://schemas.openxmlformats.org/drawingml/2006/main" xmlns:p="http://schemas.openxmlformats.org/presentationml/2006/main" xmlns:r="http://schemas.openxmlformats.org/officeDocument/2006/relationships">
+<p:sld xmlns:a="http://schemas.openxmlformats.org/drawingml/2006/main" xmlns:r="http://schemas.openxmlformats.org/officeDocument/2006/relationships" xmlns:p="http://schemas.openxmlformats.org/presentationml/2006/main">
   <p:cSld>
     <p:bg>
       <p:bgPr>
@@ -3386,7 +3427,14 @@
         <p:cNvGrpSpPr/>
         <p:nvPr/>
       </p:nvGrpSpPr>
-      <p:grpSpPr/>
+      <p:grpSpPr>
+        <a:xfrm>
+          <a:off x="0" y="0"/>
+          <a:ext cx="0" cy="0"/>
+          <a:chOff x="0" y="0"/>
+          <a:chExt cx="0" cy="0"/>
+        </a:xfrm>
+      </p:grpSpPr>
       <p:sp>
         <p:nvSpPr>
           <p:cNvPr id="2" name="Rectangle 1"/>
@@ -3427,6 +3475,7 @@
           <a:lstStyle/>
           <a:p>
             <a:pPr algn="ctr"/>
+            <a:endParaRPr/>
           </a:p>
         </p:txBody>
       </p:sp>
@@ -3470,6 +3519,7 @@
           <a:lstStyle/>
           <a:p>
             <a:pPr algn="ctr"/>
+            <a:endParaRPr/>
           </a:p>
         </p:txBody>
       </p:sp>
@@ -3649,6 +3699,7 @@
           <a:lstStyle/>
           <a:p>
             <a:pPr algn="ctr"/>
+            <a:endParaRPr/>
           </a:p>
         </p:txBody>
       </p:sp>
@@ -3763,7 +3814,7 @@
 </file>
 
 <file path=ppt/slides/slide2.xml><?xml version="1.0" encoding="utf-8"?>
-<p:sld xmlns:a="http://schemas.openxmlformats.org/drawingml/2006/main" xmlns:p="http://schemas.openxmlformats.org/presentationml/2006/main" xmlns:r="http://schemas.openxmlformats.org/officeDocument/2006/relationships">
+<p:sld xmlns:a="http://schemas.openxmlformats.org/drawingml/2006/main" xmlns:r="http://schemas.openxmlformats.org/officeDocument/2006/relationships" xmlns:p="http://schemas.openxmlformats.org/presentationml/2006/main">
   <p:cSld>
     <p:bg>
       <p:bgPr>
@@ -3779,7 +3830,14 @@
         <p:cNvGrpSpPr/>
         <p:nvPr/>
       </p:nvGrpSpPr>
-      <p:grpSpPr/>
+      <p:grpSpPr>
+        <a:xfrm>
+          <a:off x="0" y="0"/>
+          <a:ext cx="0" cy="0"/>
+          <a:chOff x="0" y="0"/>
+          <a:chExt cx="0" cy="0"/>
+        </a:xfrm>
+      </p:grpSpPr>
       <p:sp>
         <p:nvSpPr>
           <p:cNvPr id="2" name="Rectangle 1"/>
@@ -3820,6 +3878,7 @@
           <a:lstStyle/>
           <a:p>
             <a:pPr algn="ctr"/>
+            <a:endParaRPr/>
           </a:p>
         </p:txBody>
       </p:sp>
@@ -4101,6 +4160,7 @@
           <a:lstStyle/>
           <a:p>
             <a:pPr algn="ctr"/>
+            <a:endParaRPr/>
           </a:p>
         </p:txBody>
       </p:sp>
@@ -4147,7 +4207,7 @@
 </file>
 
 <file path=ppt/slides/slide3.xml><?xml version="1.0" encoding="utf-8"?>
-<p:sld xmlns:a="http://schemas.openxmlformats.org/drawingml/2006/main" xmlns:p="http://schemas.openxmlformats.org/presentationml/2006/main" xmlns:r="http://schemas.openxmlformats.org/officeDocument/2006/relationships">
+<p:sld xmlns:a="http://schemas.openxmlformats.org/drawingml/2006/main" xmlns:r="http://schemas.openxmlformats.org/officeDocument/2006/relationships" xmlns:p="http://schemas.openxmlformats.org/presentationml/2006/main">
   <p:cSld>
     <p:bg>
       <p:bgPr>
@@ -4163,7 +4223,14 @@
         <p:cNvGrpSpPr/>
         <p:nvPr/>
       </p:nvGrpSpPr>
-      <p:grpSpPr/>
+      <p:grpSpPr>
+        <a:xfrm>
+          <a:off x="0" y="0"/>
+          <a:ext cx="0" cy="0"/>
+          <a:chOff x="0" y="0"/>
+          <a:chExt cx="0" cy="0"/>
+        </a:xfrm>
+      </p:grpSpPr>
       <p:sp>
         <p:nvSpPr>
           <p:cNvPr id="2" name="Rectangle 1"/>
@@ -4204,6 +4271,7 @@
           <a:lstStyle/>
           <a:p>
             <a:pPr algn="ctr"/>
+            <a:endParaRPr/>
           </a:p>
         </p:txBody>
       </p:sp>
@@ -4315,6 +4383,7 @@
           <a:lstStyle/>
           <a:p>
             <a:pPr algn="ctr"/>
+            <a:endParaRPr/>
           </a:p>
         </p:txBody>
       </p:sp>
@@ -4460,6 +4529,7 @@
           <a:lstStyle/>
           <a:p>
             <a:pPr algn="ctr"/>
+            <a:endParaRPr/>
           </a:p>
         </p:txBody>
       </p:sp>
@@ -4605,6 +4675,7 @@
           <a:lstStyle/>
           <a:p>
             <a:pPr algn="ctr"/>
+            <a:endParaRPr/>
           </a:p>
         </p:txBody>
       </p:sp>
@@ -4719,7 +4790,7 @@
 </file>
 
 <file path=ppt/slides/slide4.xml><?xml version="1.0" encoding="utf-8"?>
-<p:sld xmlns:a="http://schemas.openxmlformats.org/drawingml/2006/main" xmlns:p="http://schemas.openxmlformats.org/presentationml/2006/main" xmlns:r="http://schemas.openxmlformats.org/officeDocument/2006/relationships">
+<p:sld xmlns:a="http://schemas.openxmlformats.org/drawingml/2006/main" xmlns:r="http://schemas.openxmlformats.org/officeDocument/2006/relationships" xmlns:p="http://schemas.openxmlformats.org/presentationml/2006/main">
   <p:cSld>
     <p:bg>
       <p:bgPr>
@@ -4735,7 +4806,14 @@
         <p:cNvGrpSpPr/>
         <p:nvPr/>
       </p:nvGrpSpPr>
-      <p:grpSpPr/>
+      <p:grpSpPr>
+        <a:xfrm>
+          <a:off x="0" y="0"/>
+          <a:ext cx="0" cy="0"/>
+          <a:chOff x="0" y="0"/>
+          <a:chExt cx="0" cy="0"/>
+        </a:xfrm>
+      </p:grpSpPr>
       <p:sp>
         <p:nvSpPr>
           <p:cNvPr id="2" name="Rectangle 1"/>
@@ -4776,6 +4854,7 @@
           <a:lstStyle/>
           <a:p>
             <a:pPr algn="ctr"/>
+            <a:endParaRPr/>
           </a:p>
         </p:txBody>
       </p:sp>
@@ -4853,6 +4932,7 @@
           <a:lstStyle/>
           <a:p>
             <a:pPr algn="ctr"/>
+            <a:endParaRPr/>
           </a:p>
         </p:txBody>
       </p:sp>
@@ -4930,6 +5010,7 @@
           <a:lstStyle/>
           <a:p>
             <a:pPr algn="ctr"/>
+            <a:endParaRPr/>
           </a:p>
         </p:txBody>
       </p:sp>
@@ -5001,6 +5082,66 @@
           </a:p>
         </p:txBody>
       </p:sp>
+      <p:pic>
+        <p:nvPicPr>
+          <p:cNvPr id="10" name="Picture 9">
+            <a:extLst>
+              <a:ext uri="{FF2B5EF4-FFF2-40B4-BE49-F238E27FC236}">
+                <a16:creationId xmlns:a16="http://schemas.microsoft.com/office/drawing/2014/main" id="{D624933B-CFA8-B84D-6796-22BFC81624A2}"/>
+              </a:ext>
+            </a:extLst>
+          </p:cNvPr>
+          <p:cNvPicPr>
+            <a:picLocks noChangeAspect="1"/>
+          </p:cNvPicPr>
+          <p:nvPr/>
+        </p:nvPicPr>
+        <p:blipFill>
+          <a:blip r:embed="rId2"/>
+          <a:stretch>
+            <a:fillRect/>
+          </a:stretch>
+        </p:blipFill>
+        <p:spPr>
+          <a:xfrm>
+            <a:off x="457200" y="1097280"/>
+            <a:ext cx="5303520" cy="3200400"/>
+          </a:xfrm>
+          <a:prstGeom prst="rect">
+            <a:avLst/>
+          </a:prstGeom>
+        </p:spPr>
+      </p:pic>
+      <p:pic>
+        <p:nvPicPr>
+          <p:cNvPr id="12" name="Picture 11">
+            <a:extLst>
+              <a:ext uri="{FF2B5EF4-FFF2-40B4-BE49-F238E27FC236}">
+                <a16:creationId xmlns:a16="http://schemas.microsoft.com/office/drawing/2014/main" id="{901E060D-D31E-58C2-8AA3-515983F80EBA}"/>
+              </a:ext>
+            </a:extLst>
+          </p:cNvPr>
+          <p:cNvPicPr>
+            <a:picLocks noChangeAspect="1"/>
+          </p:cNvPicPr>
+          <p:nvPr/>
+        </p:nvPicPr>
+        <p:blipFill>
+          <a:blip r:embed="rId3"/>
+          <a:stretch>
+            <a:fillRect/>
+          </a:stretch>
+        </p:blipFill>
+        <p:spPr>
+          <a:xfrm>
+            <a:off x="6217920" y="1097281"/>
+            <a:ext cx="5303520" cy="3200400"/>
+          </a:xfrm>
+          <a:prstGeom prst="rect">
+            <a:avLst/>
+          </a:prstGeom>
+        </p:spPr>
+      </p:pic>
     </p:spTree>
   </p:cSld>
   <p:clrMapOvr>
@@ -5010,7 +5151,7 @@
 </file>
 
 <file path=ppt/slides/slide5.xml><?xml version="1.0" encoding="utf-8"?>
-<p:sld xmlns:a="http://schemas.openxmlformats.org/drawingml/2006/main" xmlns:p="http://schemas.openxmlformats.org/presentationml/2006/main" xmlns:r="http://schemas.openxmlformats.org/officeDocument/2006/relationships">
+<p:sld xmlns:a="http://schemas.openxmlformats.org/drawingml/2006/main" xmlns:r="http://schemas.openxmlformats.org/officeDocument/2006/relationships" xmlns:p="http://schemas.openxmlformats.org/presentationml/2006/main">
   <p:cSld>
     <p:bg>
       <p:bgPr>
@@ -5026,7 +5167,14 @@
         <p:cNvGrpSpPr/>
         <p:nvPr/>
       </p:nvGrpSpPr>
-      <p:grpSpPr/>
+      <p:grpSpPr>
+        <a:xfrm>
+          <a:off x="0" y="0"/>
+          <a:ext cx="0" cy="0"/>
+          <a:chOff x="0" y="0"/>
+          <a:chExt cx="0" cy="0"/>
+        </a:xfrm>
+      </p:grpSpPr>
       <p:sp>
         <p:nvSpPr>
           <p:cNvPr id="2" name="Rectangle 1"/>
@@ -5067,6 +5215,7 @@
           <a:lstStyle/>
           <a:p>
             <a:pPr algn="ctr"/>
+            <a:endParaRPr/>
           </a:p>
         </p:txBody>
       </p:sp>
@@ -5144,6 +5293,7 @@
           <a:lstStyle/>
           <a:p>
             <a:pPr algn="ctr"/>
+            <a:endParaRPr/>
           </a:p>
         </p:txBody>
       </p:sp>
@@ -5256,6 +5406,7 @@
           <a:lstStyle/>
           <a:p>
             <a:pPr algn="ctr"/>
+            <a:endParaRPr/>
           </a:p>
         </p:txBody>
       </p:sp>
@@ -5368,6 +5519,7 @@
           <a:lstStyle/>
           <a:p>
             <a:pPr algn="ctr"/>
+            <a:endParaRPr/>
           </a:p>
         </p:txBody>
       </p:sp>
@@ -5480,6 +5632,7 @@
           <a:lstStyle/>
           <a:p>
             <a:pPr algn="ctr"/>
+            <a:endParaRPr/>
           </a:p>
         </p:txBody>
       </p:sp>
@@ -5592,6 +5745,7 @@
           <a:lstStyle/>
           <a:p>
             <a:pPr algn="ctr"/>
+            <a:endParaRPr/>
           </a:p>
         </p:txBody>
       </p:sp>
@@ -5673,7 +5827,7 @@
 </file>
 
 <file path=ppt/slides/slide6.xml><?xml version="1.0" encoding="utf-8"?>
-<p:sld xmlns:a="http://schemas.openxmlformats.org/drawingml/2006/main" xmlns:p="http://schemas.openxmlformats.org/presentationml/2006/main" xmlns:r="http://schemas.openxmlformats.org/officeDocument/2006/relationships">
+<p:sld xmlns:a="http://schemas.openxmlformats.org/drawingml/2006/main" xmlns:r="http://schemas.openxmlformats.org/officeDocument/2006/relationships" xmlns:p="http://schemas.openxmlformats.org/presentationml/2006/main">
   <p:cSld>
     <p:bg>
       <p:bgPr>
@@ -5689,7 +5843,14 @@
         <p:cNvGrpSpPr/>
         <p:nvPr/>
       </p:nvGrpSpPr>
-      <p:grpSpPr/>
+      <p:grpSpPr>
+        <a:xfrm>
+          <a:off x="0" y="0"/>
+          <a:ext cx="0" cy="0"/>
+          <a:chOff x="0" y="0"/>
+          <a:chExt cx="0" cy="0"/>
+        </a:xfrm>
+      </p:grpSpPr>
       <p:sp>
         <p:nvSpPr>
           <p:cNvPr id="2" name="Rectangle 1"/>
@@ -5730,6 +5891,7 @@
           <a:lstStyle/>
           <a:p>
             <a:pPr algn="ctr"/>
+            <a:endParaRPr/>
           </a:p>
         </p:txBody>
       </p:sp>
@@ -5807,6 +5969,7 @@
           <a:lstStyle/>
           <a:p>
             <a:pPr algn="ctr"/>
+            <a:endParaRPr/>
           </a:p>
         </p:txBody>
       </p:sp>
@@ -5918,6 +6081,7 @@
           <a:lstStyle/>
           <a:p>
             <a:pPr algn="ctr"/>
+            <a:endParaRPr/>
           </a:p>
         </p:txBody>
       </p:sp>
@@ -6029,6 +6193,7 @@
           <a:lstStyle/>
           <a:p>
             <a:pPr algn="ctr"/>
+            <a:endParaRPr/>
           </a:p>
         </p:txBody>
       </p:sp>
@@ -6140,6 +6305,7 @@
           <a:lstStyle/>
           <a:p>
             <a:pPr algn="ctr"/>
+            <a:endParaRPr/>
           </a:p>
         </p:txBody>
       </p:sp>
@@ -6251,6 +6417,7 @@
           <a:lstStyle/>
           <a:p>
             <a:pPr algn="ctr"/>
+            <a:endParaRPr/>
           </a:p>
         </p:txBody>
       </p:sp>
@@ -6297,7 +6464,7 @@
 </file>
 
 <file path=ppt/slides/slide7.xml><?xml version="1.0" encoding="utf-8"?>
-<p:sld xmlns:a="http://schemas.openxmlformats.org/drawingml/2006/main" xmlns:p="http://schemas.openxmlformats.org/presentationml/2006/main" xmlns:r="http://schemas.openxmlformats.org/officeDocument/2006/relationships">
+<p:sld xmlns:a="http://schemas.openxmlformats.org/drawingml/2006/main" xmlns:r="http://schemas.openxmlformats.org/officeDocument/2006/relationships" xmlns:p="http://schemas.openxmlformats.org/presentationml/2006/main">
   <p:cSld>
     <p:bg>
       <p:bgPr>
@@ -6313,7 +6480,14 @@
         <p:cNvGrpSpPr/>
         <p:nvPr/>
       </p:nvGrpSpPr>
-      <p:grpSpPr/>
+      <p:grpSpPr>
+        <a:xfrm>
+          <a:off x="0" y="0"/>
+          <a:ext cx="0" cy="0"/>
+          <a:chOff x="0" y="0"/>
+          <a:chExt cx="0" cy="0"/>
+        </a:xfrm>
+      </p:grpSpPr>
       <p:sp>
         <p:nvSpPr>
           <p:cNvPr id="2" name="Rectangle 1"/>
@@ -6354,6 +6528,7 @@
           <a:lstStyle/>
           <a:p>
             <a:pPr algn="ctr"/>
+            <a:endParaRPr/>
           </a:p>
         </p:txBody>
       </p:sp>
@@ -6431,6 +6606,7 @@
           <a:lstStyle/>
           <a:p>
             <a:pPr algn="ctr"/>
+            <a:endParaRPr/>
           </a:p>
         </p:txBody>
       </p:sp>
@@ -6542,6 +6718,7 @@
           <a:lstStyle/>
           <a:p>
             <a:pPr algn="ctr"/>
+            <a:endParaRPr/>
           </a:p>
         </p:txBody>
       </p:sp>
@@ -6653,6 +6830,7 @@
           <a:lstStyle/>
           <a:p>
             <a:pPr algn="ctr"/>
+            <a:endParaRPr/>
           </a:p>
         </p:txBody>
       </p:sp>
@@ -6764,6 +6942,7 @@
           <a:lstStyle/>
           <a:p>
             <a:pPr algn="ctr"/>
+            <a:endParaRPr/>
           </a:p>
         </p:txBody>
       </p:sp>
@@ -6878,7 +7057,7 @@
 </file>
 
 <file path=ppt/slides/slide8.xml><?xml version="1.0" encoding="utf-8"?>
-<p:sld xmlns:a="http://schemas.openxmlformats.org/drawingml/2006/main" xmlns:p="http://schemas.openxmlformats.org/presentationml/2006/main" xmlns:r="http://schemas.openxmlformats.org/officeDocument/2006/relationships">
+<p:sld xmlns:a="http://schemas.openxmlformats.org/drawingml/2006/main" xmlns:r="http://schemas.openxmlformats.org/officeDocument/2006/relationships" xmlns:p="http://schemas.openxmlformats.org/presentationml/2006/main">
   <p:cSld>
     <p:bg>
       <p:bgPr>
@@ -6894,7 +7073,14 @@
         <p:cNvGrpSpPr/>
         <p:nvPr/>
       </p:nvGrpSpPr>
-      <p:grpSpPr/>
+      <p:grpSpPr>
+        <a:xfrm>
+          <a:off x="0" y="0"/>
+          <a:ext cx="0" cy="0"/>
+          <a:chOff x="0" y="0"/>
+          <a:chExt cx="0" cy="0"/>
+        </a:xfrm>
+      </p:grpSpPr>
       <p:sp>
         <p:nvSpPr>
           <p:cNvPr id="2" name="Rectangle 1"/>
@@ -6935,6 +7121,7 @@
           <a:lstStyle/>
           <a:p>
             <a:pPr algn="ctr"/>
+            <a:endParaRPr/>
           </a:p>
         </p:txBody>
       </p:sp>
@@ -7012,6 +7199,7 @@
           <a:lstStyle/>
           <a:p>
             <a:pPr algn="ctr"/>
+            <a:endParaRPr/>
           </a:p>
         </p:txBody>
       </p:sp>
@@ -7089,6 +7277,7 @@
           <a:lstStyle/>
           <a:p>
             <a:pPr algn="ctr"/>
+            <a:endParaRPr/>
           </a:p>
         </p:txBody>
       </p:sp>
@@ -7166,6 +7355,7 @@
           <a:lstStyle/>
           <a:p>
             <a:pPr algn="ctr"/>
+            <a:endParaRPr/>
           </a:p>
         </p:txBody>
       </p:sp>
@@ -7243,6 +7433,7 @@
           <a:lstStyle/>
           <a:p>
             <a:pPr algn="ctr"/>
+            <a:endParaRPr/>
           </a:p>
         </p:txBody>
       </p:sp>
@@ -7320,6 +7511,7 @@
           <a:lstStyle/>
           <a:p>
             <a:pPr algn="ctr"/>
+            <a:endParaRPr/>
           </a:p>
         </p:txBody>
       </p:sp>
@@ -7397,6 +7589,7 @@
           <a:lstStyle/>
           <a:p>
             <a:pPr algn="ctr"/>
+            <a:endParaRPr/>
           </a:p>
         </p:txBody>
       </p:sp>
@@ -7443,7 +7636,7 @@
 </file>
 
 <file path=ppt/slides/slide9.xml><?xml version="1.0" encoding="utf-8"?>
-<p:sld xmlns:a="http://schemas.openxmlformats.org/drawingml/2006/main" xmlns:p="http://schemas.openxmlformats.org/presentationml/2006/main" xmlns:r="http://schemas.openxmlformats.org/officeDocument/2006/relationships">
+<p:sld xmlns:a="http://schemas.openxmlformats.org/drawingml/2006/main" xmlns:r="http://schemas.openxmlformats.org/officeDocument/2006/relationships" xmlns:p="http://schemas.openxmlformats.org/presentationml/2006/main">
   <p:cSld>
     <p:bg>
       <p:bgPr>
@@ -7459,7 +7652,14 @@
         <p:cNvGrpSpPr/>
         <p:nvPr/>
       </p:nvGrpSpPr>
-      <p:grpSpPr/>
+      <p:grpSpPr>
+        <a:xfrm>
+          <a:off x="0" y="0"/>
+          <a:ext cx="0" cy="0"/>
+          <a:chOff x="0" y="0"/>
+          <a:chExt cx="0" cy="0"/>
+        </a:xfrm>
+      </p:grpSpPr>
       <p:sp>
         <p:nvSpPr>
           <p:cNvPr id="2" name="Rectangle 1"/>
@@ -7500,6 +7700,7 @@
           <a:lstStyle/>
           <a:p>
             <a:pPr algn="ctr"/>
+            <a:endParaRPr/>
           </a:p>
         </p:txBody>
       </p:sp>
@@ -7577,6 +7778,7 @@
           <a:lstStyle/>
           <a:p>
             <a:pPr algn="ctr"/>
+            <a:endParaRPr/>
           </a:p>
         </p:txBody>
       </p:sp>
@@ -7688,6 +7890,7 @@
           <a:lstStyle/>
           <a:p>
             <a:pPr algn="ctr"/>
+            <a:endParaRPr/>
           </a:p>
         </p:txBody>
       </p:sp>
@@ -7799,6 +8002,7 @@
           <a:lstStyle/>
           <a:p>
             <a:pPr algn="ctr"/>
+            <a:endParaRPr/>
           </a:p>
         </p:txBody>
       </p:sp>
@@ -7910,6 +8114,7 @@
           <a:lstStyle/>
           <a:p>
             <a:pPr algn="ctr"/>
+            <a:endParaRPr/>
           </a:p>
         </p:txBody>
       </p:sp>

</xml_diff>